<commit_message>
Finalize report and presentation
</commit_message>
<xml_diff>
--- a/reports/presentation/education_admission_project_presentation_final.pptx
+++ b/reports/presentation/education_admission_project_presentation_final.pptx
@@ -2404,8 +2404,48 @@
               </a:defRPr>
             </a:pPr>
             <a:r>
-              <a:t>보고서 그림 9–10 | Power BI 대시보드용 데이터셋 및 PBIX 산출물</a:t>
-            </a:r>
+              <a:rPr dirty="0" err="1"/>
+              <a:t>보고서</a:t>
+            </a:r>
+            <a:r>
+              <a:rPr dirty="0"/>
+              <a:t> </a:t>
+            </a:r>
+            <a:r>
+              <a:rPr dirty="0" err="1"/>
+              <a:t>그림</a:t>
+            </a:r>
+            <a:r>
+              <a:t> 10</a:t>
+            </a:r>
+            <a:r>
+              <a:rPr lang="en-US"/>
+              <a:t>-11</a:t>
+            </a:r>
+            <a:r>
+              <a:t> | Power BI </a:t>
+            </a:r>
+            <a:r>
+              <a:rPr dirty="0" err="1"/>
+              <a:t>대시보드용</a:t>
+            </a:r>
+            <a:r>
+              <a:rPr dirty="0"/>
+              <a:t> </a:t>
+            </a:r>
+            <a:r>
+              <a:rPr dirty="0" err="1"/>
+              <a:t>데이터셋</a:t>
+            </a:r>
+            <a:r>
+              <a:rPr dirty="0"/>
+              <a:t> 및 PBIX </a:t>
+            </a:r>
+            <a:r>
+              <a:rPr dirty="0" err="1"/>
+              <a:t>산출물</a:t>
+            </a:r>
+            <a:endParaRPr dirty="0"/>
           </a:p>
         </p:txBody>
       </p:sp>
@@ -18834,7 +18874,15 @@
             </a:r>
             <a:r>
               <a:rPr dirty="0"/>
-              <a:t> 7–8 | </a:t>
+              <a:t> </a:t>
+            </a:r>
+            <a:r>
+              <a:rPr lang="en-US" dirty="0"/>
+              <a:t>8-9</a:t>
+            </a:r>
+            <a:r>
+              <a:rPr dirty="0"/>
+              <a:t> | </a:t>
             </a:r>
             <a:r>
               <a:rPr lang="ko-KR" altLang="ko-KR" sz="900" dirty="0" err="1"/>

</xml_diff>